<commit_message>
Remove empty page in ppt
</commit_message>
<xml_diff>
--- a/docs/Presentation_Team_23.pptx
+++ b/docs/Presentation_Team_23.pptx
@@ -5,7 +5,7 @@
     <p:sldMasterId id="2147483648" r:id="rId1"/>
   </p:sldMasterIdLst>
   <p:notesMasterIdLst>
-    <p:notesMasterId r:id="rId16"/>
+    <p:notesMasterId r:id="rId15"/>
   </p:notesMasterIdLst>
   <p:sldIdLst>
     <p:sldId id="256" r:id="rId2"/>
@@ -17,11 +17,10 @@
     <p:sldId id="262" r:id="rId8"/>
     <p:sldId id="263" r:id="rId9"/>
     <p:sldId id="264" r:id="rId10"/>
-    <p:sldId id="265" r:id="rId11"/>
-    <p:sldId id="266" r:id="rId12"/>
-    <p:sldId id="267" r:id="rId13"/>
-    <p:sldId id="268" r:id="rId14"/>
-    <p:sldId id="269" r:id="rId15"/>
+    <p:sldId id="266" r:id="rId11"/>
+    <p:sldId id="267" r:id="rId12"/>
+    <p:sldId id="268" r:id="rId13"/>
+    <p:sldId id="269" r:id="rId14"/>
   </p:sldIdLst>
   <p:sldSz cx="9144000" cy="5143500" type="screen16x9"/>
   <p:notesSz cx="5143500" cy="9144000"/>
@@ -139,7 +138,6 @@
             <p14:sldId id="262"/>
             <p14:sldId id="263"/>
             <p14:sldId id="264"/>
-            <p14:sldId id="265"/>
             <p14:sldId id="266"/>
           </p14:sldIdLst>
         </p14:section>
@@ -181,7 +179,7 @@
               </a:defRPr>
             </a:pPr>
             <a:r>
-              <a:rPr sz="1300" b="0" i="0" u="none" strike="noStrike">
+              <a:rPr lang="en-US" sz="1300" b="0" i="0" u="none" strike="noStrike">
                 <a:solidFill>
                   <a:srgbClr val="1B1033"/>
                 </a:solidFill>
@@ -596,7 +594,7 @@
               </a:defRPr>
             </a:pPr>
             <a:r>
-              <a:rPr sz="1300" b="0" i="0" u="none" strike="noStrike">
+              <a:rPr lang="en-US" sz="1300" b="0" i="0" u="none" strike="noStrike">
                 <a:solidFill>
                   <a:srgbClr val="1B1033"/>
                 </a:solidFill>
@@ -987,7 +985,7 @@
               </a:defRPr>
             </a:pPr>
             <a:r>
-              <a:rPr sz="1300" b="0" i="0" u="none" strike="noStrike">
+              <a:rPr lang="en-US" sz="1300" b="0" i="0" u="none" strike="noStrike">
                 <a:solidFill>
                   <a:srgbClr val="1B1033"/>
                 </a:solidFill>
@@ -1406,12 +1404,6 @@
             <c:idx val="0"/>
             <c:invertIfNegative val="0"/>
             <c:bubble3D val="0"/>
-            <c:spPr>
-              <a:solidFill>
-                <a:srgbClr val="1F9E94"/>
-              </a:solidFill>
-              <a:effectLst/>
-            </c:spPr>
             <c:extLst>
               <c:ext xmlns:c16="http://schemas.microsoft.com/office/drawing/2014/chart" uri="{C3380CC4-5D6E-409C-BE32-E72D297353CC}">
                 <c16:uniqueId val="{00000001-5C18-4D4A-8900-4D0CF0E2D3E7}"/>
@@ -1422,12 +1414,6 @@
             <c:idx val="1"/>
             <c:invertIfNegative val="0"/>
             <c:bubble3D val="0"/>
-            <c:spPr>
-              <a:solidFill>
-                <a:srgbClr val="1F9E94"/>
-              </a:solidFill>
-              <a:effectLst/>
-            </c:spPr>
             <c:extLst>
               <c:ext xmlns:c16="http://schemas.microsoft.com/office/drawing/2014/chart" uri="{C3380CC4-5D6E-409C-BE32-E72D297353CC}">
                 <c16:uniqueId val="{00000003-5C18-4D4A-8900-4D0CF0E2D3E7}"/>
@@ -1438,12 +1424,6 @@
             <c:idx val="2"/>
             <c:invertIfNegative val="0"/>
             <c:bubble3D val="0"/>
-            <c:spPr>
-              <a:solidFill>
-                <a:srgbClr val="1F9E94"/>
-              </a:solidFill>
-              <a:effectLst/>
-            </c:spPr>
             <c:extLst>
               <c:ext xmlns:c16="http://schemas.microsoft.com/office/drawing/2014/chart" uri="{C3380CC4-5D6E-409C-BE32-E72D297353CC}">
                 <c16:uniqueId val="{00000005-5C18-4D4A-8900-4D0CF0E2D3E7}"/>
@@ -1454,12 +1434,6 @@
             <c:idx val="3"/>
             <c:invertIfNegative val="0"/>
             <c:bubble3D val="0"/>
-            <c:spPr>
-              <a:solidFill>
-                <a:srgbClr val="1F9E94"/>
-              </a:solidFill>
-              <a:effectLst/>
-            </c:spPr>
             <c:extLst>
               <c:ext xmlns:c16="http://schemas.microsoft.com/office/drawing/2014/chart" uri="{C3380CC4-5D6E-409C-BE32-E72D297353CC}">
                 <c16:uniqueId val="{00000007-5C18-4D4A-8900-4D0CF0E2D3E7}"/>
@@ -1470,12 +1444,6 @@
             <c:idx val="4"/>
             <c:invertIfNegative val="0"/>
             <c:bubble3D val="0"/>
-            <c:spPr>
-              <a:solidFill>
-                <a:srgbClr val="1F9E94"/>
-              </a:solidFill>
-              <a:effectLst/>
-            </c:spPr>
             <c:extLst>
               <c:ext xmlns:c16="http://schemas.microsoft.com/office/drawing/2014/chart" uri="{C3380CC4-5D6E-409C-BE32-E72D297353CC}">
                 <c16:uniqueId val="{00000009-5C18-4D4A-8900-4D0CF0E2D3E7}"/>
@@ -1486,12 +1454,6 @@
             <c:idx val="5"/>
             <c:invertIfNegative val="0"/>
             <c:bubble3D val="0"/>
-            <c:spPr>
-              <a:solidFill>
-                <a:srgbClr val="1F9E94"/>
-              </a:solidFill>
-              <a:effectLst/>
-            </c:spPr>
             <c:extLst>
               <c:ext xmlns:c16="http://schemas.microsoft.com/office/drawing/2014/chart" uri="{C3380CC4-5D6E-409C-BE32-E72D297353CC}">
                 <c16:uniqueId val="{0000000B-5C18-4D4A-8900-4D0CF0E2D3E7}"/>
@@ -1502,12 +1464,6 @@
             <c:idx val="6"/>
             <c:invertIfNegative val="0"/>
             <c:bubble3D val="0"/>
-            <c:spPr>
-              <a:solidFill>
-                <a:srgbClr val="1F9E94"/>
-              </a:solidFill>
-              <a:effectLst/>
-            </c:spPr>
             <c:extLst>
               <c:ext xmlns:c16="http://schemas.microsoft.com/office/drawing/2014/chart" uri="{C3380CC4-5D6E-409C-BE32-E72D297353CC}">
                 <c16:uniqueId val="{0000000D-5C18-4D4A-8900-4D0CF0E2D3E7}"/>
@@ -2528,7 +2484,7 @@
           <a:p>
             <a:fld id="{F7021451-1387-4CA6-816F-3879F97B5CBC}" type="slidenum">
               <a:rPr lang="en-US"/>
-              <a:t>11</a:t>
+              <a:t>10</a:t>
             </a:fld>
             <a:endParaRPr lang="en-US"/>
           </a:p>
@@ -2615,7 +2571,7 @@
           <a:p>
             <a:fld id="{F7021451-1387-4CA6-816F-3879F97B5CBC}" type="slidenum">
               <a:rPr lang="en-US"/>
-              <a:t>12</a:t>
+              <a:t>11</a:t>
             </a:fld>
             <a:endParaRPr lang="en-US"/>
           </a:p>
@@ -2702,7 +2658,7 @@
           <a:p>
             <a:fld id="{F7021451-1387-4CA6-816F-3879F97B5CBC}" type="slidenum">
               <a:rPr lang="en-US"/>
-              <a:t>13</a:t>
+              <a:t>12</a:t>
             </a:fld>
             <a:endParaRPr lang="en-US"/>
           </a:p>
@@ -2789,7 +2745,7 @@
           <a:p>
             <a:fld id="{F7021451-1387-4CA6-816F-3879F97B5CBC}" type="slidenum">
               <a:rPr lang="en-US"/>
-              <a:t>14</a:t>
+              <a:t>13</a:t>
             </a:fld>
             <a:endParaRPr lang="en-US"/>
           </a:p>
@@ -3771,7 +3727,7 @@
           </a:prstGeom>
           <a:extLst>
             <a:ext uri="{C572A759-6A51-4108-AA02-DFA0A04FC94B}">
-              <ma14:wrappingTextBoxFlag xmlns:ma14="http://schemas.microsoft.com/office/mac/drawingml/2011/main" xmlns="" val="0"/>
+              <ma14:wrappingTextBoxFlag xmlns="" xmlns:ma14="http://schemas.microsoft.com/office/mac/drawingml/2011/main" val="0"/>
             </a:ext>
           </a:extLst>
         </p:spPr>
@@ -3890,7 +3846,7 @@
           </a:prstGeom>
           <a:extLst>
             <a:ext uri="{C572A759-6A51-4108-AA02-DFA0A04FC94B}">
-              <ma14:wrappingTextBoxFlag xmlns:ma14="http://schemas.microsoft.com/office/mac/drawingml/2011/main" xmlns="" val="0"/>
+              <ma14:wrappingTextBoxFlag xmlns="" xmlns:ma14="http://schemas.microsoft.com/office/mac/drawingml/2011/main" val="0"/>
             </a:ext>
           </a:extLst>
         </p:spPr>
@@ -3965,7 +3921,7 @@
           </a:prstGeom>
           <a:extLst>
             <a:ext uri="{C572A759-6A51-4108-AA02-DFA0A04FC94B}">
-              <ma14:wrappingTextBoxFlag xmlns:ma14="http://schemas.microsoft.com/office/mac/drawingml/2011/main" xmlns="" val="0"/>
+              <ma14:wrappingTextBoxFlag xmlns="" xmlns:ma14="http://schemas.microsoft.com/office/mac/drawingml/2011/main" val="0"/>
             </a:ext>
           </a:extLst>
         </p:spPr>
@@ -4380,7 +4336,7 @@
                   <a:schemeClr val="bg1"/>
                 </a:solidFill>
               </a:rPr>
-              <a:t>Rekha Dhorigol  PES1UG24CS370</a:t>
+              <a:t>Rekha Dhorigol - PES1UG24CS370</a:t>
             </a:r>
             <a:endParaRPr lang="en-US" sz="1600" dirty="0"/>
           </a:p>
@@ -4394,7 +4350,7 @@
                   <a:schemeClr val="bg1"/>
                 </a:solidFill>
               </a:rPr>
-              <a:t>Sai Manogna B V  PES1UG24CS399</a:t>
+              <a:t>Sai Manogna B V - PES1UG24CS399</a:t>
             </a:r>
             <a:endParaRPr lang="en-US" sz="1600" dirty="0"/>
           </a:p>
@@ -4513,31 +4469,6 @@
 </file>
 
 <file path=ppt/slides/slide10.xml><?xml version="1.0" encoding="utf-8"?>
-<p:sld xmlns:a="http://schemas.openxmlformats.org/drawingml/2006/main" xmlns:r="http://schemas.openxmlformats.org/officeDocument/2006/relationships" xmlns:p="http://schemas.openxmlformats.org/presentationml/2006/main">
-  <p:cSld>
-    <p:spTree>
-      <p:nvGrpSpPr>
-        <p:cNvPr id="1" name=""/>
-        <p:cNvGrpSpPr/>
-        <p:nvPr/>
-      </p:nvGrpSpPr>
-      <p:grpSpPr>
-        <a:xfrm>
-          <a:off x="0" y="0"/>
-          <a:ext cx="0" cy="0"/>
-          <a:chOff x="0" y="0"/>
-          <a:chExt cx="0" cy="0"/>
-        </a:xfrm>
-      </p:grpSpPr>
-    </p:spTree>
-  </p:cSld>
-  <p:clrMapOvr>
-    <a:masterClrMapping/>
-  </p:clrMapOvr>
-</p:sld>
-</file>
-
-<file path=ppt/slides/slide11.xml><?xml version="1.0" encoding="utf-8"?>
 <p:sld xmlns:a="http://schemas.openxmlformats.org/drawingml/2006/main" xmlns:r="http://schemas.openxmlformats.org/officeDocument/2006/relationships" xmlns:p="http://schemas.openxmlformats.org/presentationml/2006/main">
   <p:cSld name="Slide 11">
     <p:spTree>
@@ -4855,7 +4786,7 @@
           </a:prstGeom>
           <a:extLst>
             <a:ext uri="{C572A759-6A51-4108-AA02-DFA0A04FC94B}">
-              <ma14:wrappingTextBoxFlag xmlns:ma14="http://schemas.microsoft.com/office/mac/drawingml/2011/main" xmlns="" val="0"/>
+              <ma14:wrappingTextBoxFlag xmlns="" xmlns:ma14="http://schemas.microsoft.com/office/mac/drawingml/2011/main" val="0"/>
             </a:ext>
           </a:extLst>
         </p:spPr>
@@ -4874,7 +4805,7 @@
             <a:pPr algn="l"/>
             <a:fld id="{F7021451-1387-4CA6-816F-3879F97B5CBC}" type="slidenum">
               <a:rPr lang="en-US" b="0"/>
-              <a:t>11</a:t>
+              <a:t>10</a:t>
             </a:fld>
             <a:endParaRPr lang="en-US"/>
           </a:p>
@@ -4888,7 +4819,7 @@
 </p:sld>
 </file>
 
-<file path=ppt/slides/slide12.xml><?xml version="1.0" encoding="utf-8"?>
+<file path=ppt/slides/slide11.xml><?xml version="1.0" encoding="utf-8"?>
 <p:sld xmlns:a="http://schemas.openxmlformats.org/drawingml/2006/main" xmlns:r="http://schemas.openxmlformats.org/officeDocument/2006/relationships" xmlns:p="http://schemas.openxmlformats.org/presentationml/2006/main">
   <p:cSld name="Slide 12">
     <p:spTree>
@@ -5654,7 +5585,7 @@
           </a:prstGeom>
           <a:extLst>
             <a:ext uri="{C572A759-6A51-4108-AA02-DFA0A04FC94B}">
-              <ma14:wrappingTextBoxFlag xmlns:ma14="http://schemas.microsoft.com/office/mac/drawingml/2011/main" xmlns="" val="0"/>
+              <ma14:wrappingTextBoxFlag xmlns="" xmlns:ma14="http://schemas.microsoft.com/office/mac/drawingml/2011/main" val="0"/>
             </a:ext>
           </a:extLst>
         </p:spPr>
@@ -5673,7 +5604,7 @@
             <a:pPr algn="l"/>
             <a:fld id="{F7021451-1387-4CA6-816F-3879F97B5CBC}" type="slidenum">
               <a:rPr lang="en-US" b="0"/>
-              <a:t>12</a:t>
+              <a:t>11</a:t>
             </a:fld>
             <a:endParaRPr lang="en-US"/>
           </a:p>
@@ -5687,7 +5618,7 @@
 </p:sld>
 </file>
 
-<file path=ppt/slides/slide13.xml><?xml version="1.0" encoding="utf-8"?>
+<file path=ppt/slides/slide12.xml><?xml version="1.0" encoding="utf-8"?>
 <p:sld xmlns:a="http://schemas.openxmlformats.org/drawingml/2006/main" xmlns:r="http://schemas.openxmlformats.org/officeDocument/2006/relationships" xmlns:p="http://schemas.openxmlformats.org/presentationml/2006/main">
   <p:cSld name="Slide 13">
     <p:spTree>
@@ -6276,7 +6207,7 @@
           </a:prstGeom>
           <a:extLst>
             <a:ext uri="{C572A759-6A51-4108-AA02-DFA0A04FC94B}">
-              <ma14:wrappingTextBoxFlag xmlns:ma14="http://schemas.microsoft.com/office/mac/drawingml/2011/main" xmlns="" val="0"/>
+              <ma14:wrappingTextBoxFlag xmlns="" xmlns:ma14="http://schemas.microsoft.com/office/mac/drawingml/2011/main" val="0"/>
             </a:ext>
           </a:extLst>
         </p:spPr>
@@ -6295,7 +6226,7 @@
             <a:pPr algn="l"/>
             <a:fld id="{F7021451-1387-4CA6-816F-3879F97B5CBC}" type="slidenum">
               <a:rPr lang="en-US" b="0"/>
-              <a:t>13</a:t>
+              <a:t>12</a:t>
             </a:fld>
             <a:endParaRPr lang="en-US"/>
           </a:p>
@@ -6309,7 +6240,7 @@
 </p:sld>
 </file>
 
-<file path=ppt/slides/slide14.xml><?xml version="1.0" encoding="utf-8"?>
+<file path=ppt/slides/slide13.xml><?xml version="1.0" encoding="utf-8"?>
 <p:sld xmlns:a="http://schemas.openxmlformats.org/drawingml/2006/main" xmlns:r="http://schemas.openxmlformats.org/officeDocument/2006/relationships" xmlns:p="http://schemas.openxmlformats.org/presentationml/2006/main">
   <p:cSld name="Slide 14">
     <p:spTree>
@@ -6678,7 +6609,7 @@
           </a:prstGeom>
           <a:extLst>
             <a:ext uri="{C572A759-6A51-4108-AA02-DFA0A04FC94B}">
-              <ma14:wrappingTextBoxFlag xmlns:ma14="http://schemas.microsoft.com/office/mac/drawingml/2011/main" xmlns="" val="0"/>
+              <ma14:wrappingTextBoxFlag xmlns="" xmlns:ma14="http://schemas.microsoft.com/office/mac/drawingml/2011/main" val="0"/>
             </a:ext>
           </a:extLst>
         </p:spPr>
@@ -6697,7 +6628,7 @@
             <a:pPr algn="l"/>
             <a:fld id="{F7021451-1387-4CA6-816F-3879F97B5CBC}" type="slidenum">
               <a:rPr lang="en-US" b="0"/>
-              <a:t>14</a:t>
+              <a:t>13</a:t>
             </a:fld>
             <a:endParaRPr lang="en-US"/>
           </a:p>
@@ -7345,7 +7276,7 @@
           </a:prstGeom>
           <a:extLst>
             <a:ext uri="{C572A759-6A51-4108-AA02-DFA0A04FC94B}">
-              <ma14:wrappingTextBoxFlag xmlns:ma14="http://schemas.microsoft.com/office/mac/drawingml/2011/main" xmlns="" val="0"/>
+              <ma14:wrappingTextBoxFlag xmlns="" xmlns:ma14="http://schemas.microsoft.com/office/mac/drawingml/2011/main" val="0"/>
             </a:ext>
           </a:extLst>
         </p:spPr>
@@ -7805,7 +7736,7 @@
           </a:prstGeom>
           <a:extLst>
             <a:ext uri="{C572A759-6A51-4108-AA02-DFA0A04FC94B}">
-              <ma14:wrappingTextBoxFlag xmlns:ma14="http://schemas.microsoft.com/office/mac/drawingml/2011/main" xmlns="" val="0"/>
+              <ma14:wrappingTextBoxFlag xmlns="" xmlns:ma14="http://schemas.microsoft.com/office/mac/drawingml/2011/main" val="0"/>
             </a:ext>
           </a:extLst>
         </p:spPr>
@@ -8516,7 +8447,7 @@
           </a:prstGeom>
           <a:extLst>
             <a:ext uri="{C572A759-6A51-4108-AA02-DFA0A04FC94B}">
-              <ma14:wrappingTextBoxFlag xmlns:ma14="http://schemas.microsoft.com/office/mac/drawingml/2011/main" xmlns="" val="0"/>
+              <ma14:wrappingTextBoxFlag xmlns="" xmlns:ma14="http://schemas.microsoft.com/office/mac/drawingml/2011/main" val="0"/>
             </a:ext>
           </a:extLst>
         </p:spPr>
@@ -9657,7 +9588,7 @@
           </a:prstGeom>
           <a:extLst>
             <a:ext uri="{C572A759-6A51-4108-AA02-DFA0A04FC94B}">
-              <ma14:wrappingTextBoxFlag xmlns:ma14="http://schemas.microsoft.com/office/mac/drawingml/2011/main" xmlns="" val="0"/>
+              <ma14:wrappingTextBoxFlag xmlns="" xmlns:ma14="http://schemas.microsoft.com/office/mac/drawingml/2011/main" val="0"/>
             </a:ext>
           </a:extLst>
         </p:spPr>
@@ -9933,7 +9864,7 @@
           </a:prstGeom>
           <a:extLst>
             <a:ext uri="{C572A759-6A51-4108-AA02-DFA0A04FC94B}">
-              <ma14:wrappingTextBoxFlag xmlns:ma14="http://schemas.microsoft.com/office/mac/drawingml/2011/main" xmlns="" val="0"/>
+              <ma14:wrappingTextBoxFlag xmlns="" xmlns:ma14="http://schemas.microsoft.com/office/mac/drawingml/2011/main" val="0"/>
             </a:ext>
           </a:extLst>
         </p:spPr>
@@ -10377,7 +10308,7 @@
           </a:prstGeom>
           <a:extLst>
             <a:ext uri="{C572A759-6A51-4108-AA02-DFA0A04FC94B}">
-              <ma14:wrappingTextBoxFlag xmlns:ma14="http://schemas.microsoft.com/office/mac/drawingml/2011/main" xmlns="" val="0"/>
+              <ma14:wrappingTextBoxFlag xmlns="" xmlns:ma14="http://schemas.microsoft.com/office/mac/drawingml/2011/main" val="0"/>
             </a:ext>
           </a:extLst>
         </p:spPr>
@@ -10728,7 +10659,7 @@
           </a:prstGeom>
           <a:extLst>
             <a:ext uri="{C572A759-6A51-4108-AA02-DFA0A04FC94B}">
-              <ma14:wrappingTextBoxFlag xmlns:ma14="http://schemas.microsoft.com/office/mac/drawingml/2011/main" xmlns="" val="0"/>
+              <ma14:wrappingTextBoxFlag xmlns="" xmlns:ma14="http://schemas.microsoft.com/office/mac/drawingml/2011/main" val="0"/>
             </a:ext>
           </a:extLst>
         </p:spPr>
@@ -10914,7 +10845,7 @@
           </a:prstGeom>
           <a:extLst>
             <a:ext uri="{C572A759-6A51-4108-AA02-DFA0A04FC94B}">
-              <ma14:wrappingTextBoxFlag xmlns:ma14="http://schemas.microsoft.com/office/mac/drawingml/2011/main" xmlns="" val="0"/>
+              <ma14:wrappingTextBoxFlag xmlns="" xmlns:ma14="http://schemas.microsoft.com/office/mac/drawingml/2011/main" val="0"/>
             </a:ext>
           </a:extLst>
         </p:spPr>

</xml_diff>